<commit_message>
Assignments: convert grid to two-column Name | Topic table
</commit_message>
<xml_diff>
--- a/docs/lectures/06_11_analysis_of_variance/anova_as_regression.pptx
+++ b/docs/lectures/06_11_analysis_of_variance/anova_as_regression.pptx
@@ -4203,7 +4203,7 @@
       </p:sp>
       <p:graphicFrame xmlns:a="http://schemas.openxmlformats.org/drawingml/2006/main" xmlns:r="http://schemas.openxmlformats.org/officeDocument/2006/relationships" xmlns:p="http://schemas.openxmlformats.org/presentationml/2006/main">
         <p:nvGraphicFramePr>
-          <p:cNvPr id="744682919" name=""/>
+          <p:cNvPr id="196509540" name=""/>
           <p:cNvGraphicFramePr>
             <a:graphicFrameLocks noGrp="true"/>
           </p:cNvGraphicFramePr>
@@ -4304,7 +4304,7 @@
       </p:sp>
       <p:graphicFrame xmlns:a="http://schemas.openxmlformats.org/drawingml/2006/main" xmlns:r="http://schemas.openxmlformats.org/officeDocument/2006/relationships" xmlns:p="http://schemas.openxmlformats.org/presentationml/2006/main">
         <p:nvGraphicFramePr>
-          <p:cNvPr id="306903911" name=""/>
+          <p:cNvPr id="215163616" name=""/>
           <p:cNvGraphicFramePr>
             <a:graphicFrameLocks noGrp="true"/>
           </p:cNvGraphicFramePr>
@@ -5187,7 +5187,7 @@
       </p:sp>
       <p:graphicFrame xmlns:a="http://schemas.openxmlformats.org/drawingml/2006/main" xmlns:r="http://schemas.openxmlformats.org/officeDocument/2006/relationships" xmlns:p="http://schemas.openxmlformats.org/presentationml/2006/main">
         <p:nvGraphicFramePr>
-          <p:cNvPr id="761718386" name=""/>
+          <p:cNvPr id="481021047" name=""/>
           <p:cNvGraphicFramePr>
             <a:graphicFrameLocks noGrp="true"/>
           </p:cNvGraphicFramePr>
@@ -6750,7 +6750,7 @@
       </p:sp>
       <p:graphicFrame xmlns:a="http://schemas.openxmlformats.org/drawingml/2006/main" xmlns:r="http://schemas.openxmlformats.org/officeDocument/2006/relationships" xmlns:p="http://schemas.openxmlformats.org/presentationml/2006/main">
         <p:nvGraphicFramePr>
-          <p:cNvPr id="46324605" name=""/>
+          <p:cNvPr id="728916074" name=""/>
           <p:cNvGraphicFramePr>
             <a:graphicFrameLocks noGrp="true"/>
           </p:cNvGraphicFramePr>

</xml_diff>